<commit_message>
set up OP Chinook LME test run for looking at length changes through time
everything is working! but need to fine tune check diagnostics etc
</commit_message>
<xml_diff>
--- a/PST_Plots_OP_Ex.pptx
+++ b/PST_Plots_OP_Ex.pptx
@@ -5,13 +5,14 @@
     <p:sldMasterId id="2147483648" r:id="rId1"/>
   </p:sldMasterIdLst>
   <p:notesMasterIdLst>
-    <p:notesMasterId r:id="rId6"/>
+    <p:notesMasterId r:id="rId7"/>
   </p:notesMasterIdLst>
   <p:sldIdLst>
-    <p:sldId id="257" r:id="rId2"/>
-    <p:sldId id="258" r:id="rId3"/>
-    <p:sldId id="259" r:id="rId4"/>
-    <p:sldId id="256" r:id="rId5"/>
+    <p:sldId id="260" r:id="rId2"/>
+    <p:sldId id="256" r:id="rId3"/>
+    <p:sldId id="257" r:id="rId4"/>
+    <p:sldId id="258" r:id="rId5"/>
+    <p:sldId id="259" r:id="rId6"/>
   </p:sldIdLst>
   <p:sldSz cx="12192000" cy="6858000"/>
   <p:notesSz cx="6858000" cy="9144000"/>
@@ -110,6 +111,11 @@
       </a:defRPr>
     </a:lvl9pPr>
   </p:defaultTextStyle>
+  <p:extLst>
+    <p:ext uri="{EFAFB233-063F-42B5-8137-9DF3F51BA10A}">
+      <p15:sldGuideLst xmlns:p15="http://schemas.microsoft.com/office/powerpoint/2012/main"/>
+    </p:ext>
+  </p:extLst>
 </p:presentation>
 </file>
 
@@ -195,7 +201,7 @@
           <a:p>
             <a:fld id="{BCE4F4D5-A8FA-8045-86D0-0BF18A9A0EB7}" type="datetimeFigureOut">
               <a:rPr lang="en-US" smtClean="0"/>
-              <a:t>1/28/26</a:t>
+              <a:t>2/2/26</a:t>
             </a:fld>
             <a:endParaRPr lang="en-US"/>
           </a:p>
@@ -626,7 +632,7 @@
           <a:p>
             <a:fld id="{9A4F1823-27E4-0F48-86A3-814342CDEA7D}" type="slidenum">
               <a:rPr lang="en-US" smtClean="0"/>
-              <a:t>4</a:t>
+              <a:t>2</a:t>
             </a:fld>
             <a:endParaRPr lang="en-US"/>
           </a:p>
@@ -792,7 +798,7 @@
           <a:p>
             <a:fld id="{4F6C1070-FC69-7346-96B1-50D36BCAB7E5}" type="datetimeFigureOut">
               <a:rPr lang="en-US" smtClean="0"/>
-              <a:t>1/28/26</a:t>
+              <a:t>2/2/26</a:t>
             </a:fld>
             <a:endParaRPr lang="en-US"/>
           </a:p>
@@ -990,7 +996,7 @@
           <a:p>
             <a:fld id="{4F6C1070-FC69-7346-96B1-50D36BCAB7E5}" type="datetimeFigureOut">
               <a:rPr lang="en-US" smtClean="0"/>
-              <a:t>1/28/26</a:t>
+              <a:t>2/2/26</a:t>
             </a:fld>
             <a:endParaRPr lang="en-US"/>
           </a:p>
@@ -1198,7 +1204,7 @@
           <a:p>
             <a:fld id="{4F6C1070-FC69-7346-96B1-50D36BCAB7E5}" type="datetimeFigureOut">
               <a:rPr lang="en-US" smtClean="0"/>
-              <a:t>1/28/26</a:t>
+              <a:t>2/2/26</a:t>
             </a:fld>
             <a:endParaRPr lang="en-US"/>
           </a:p>
@@ -1396,7 +1402,7 @@
           <a:p>
             <a:fld id="{4F6C1070-FC69-7346-96B1-50D36BCAB7E5}" type="datetimeFigureOut">
               <a:rPr lang="en-US" smtClean="0"/>
-              <a:t>1/28/26</a:t>
+              <a:t>2/2/26</a:t>
             </a:fld>
             <a:endParaRPr lang="en-US"/>
           </a:p>
@@ -1671,7 +1677,7 @@
           <a:p>
             <a:fld id="{4F6C1070-FC69-7346-96B1-50D36BCAB7E5}" type="datetimeFigureOut">
               <a:rPr lang="en-US" smtClean="0"/>
-              <a:t>1/28/26</a:t>
+              <a:t>2/2/26</a:t>
             </a:fld>
             <a:endParaRPr lang="en-US"/>
           </a:p>
@@ -1936,7 +1942,7 @@
           <a:p>
             <a:fld id="{4F6C1070-FC69-7346-96B1-50D36BCAB7E5}" type="datetimeFigureOut">
               <a:rPr lang="en-US" smtClean="0"/>
-              <a:t>1/28/26</a:t>
+              <a:t>2/2/26</a:t>
             </a:fld>
             <a:endParaRPr lang="en-US"/>
           </a:p>
@@ -2348,7 +2354,7 @@
           <a:p>
             <a:fld id="{4F6C1070-FC69-7346-96B1-50D36BCAB7E5}" type="datetimeFigureOut">
               <a:rPr lang="en-US" smtClean="0"/>
-              <a:t>1/28/26</a:t>
+              <a:t>2/2/26</a:t>
             </a:fld>
             <a:endParaRPr lang="en-US"/>
           </a:p>
@@ -2489,7 +2495,7 @@
           <a:p>
             <a:fld id="{4F6C1070-FC69-7346-96B1-50D36BCAB7E5}" type="datetimeFigureOut">
               <a:rPr lang="en-US" smtClean="0"/>
-              <a:t>1/28/26</a:t>
+              <a:t>2/2/26</a:t>
             </a:fld>
             <a:endParaRPr lang="en-US"/>
           </a:p>
@@ -2602,7 +2608,7 @@
           <a:p>
             <a:fld id="{4F6C1070-FC69-7346-96B1-50D36BCAB7E5}" type="datetimeFigureOut">
               <a:rPr lang="en-US" smtClean="0"/>
-              <a:t>1/28/26</a:t>
+              <a:t>2/2/26</a:t>
             </a:fld>
             <a:endParaRPr lang="en-US"/>
           </a:p>
@@ -2913,7 +2919,7 @@
           <a:p>
             <a:fld id="{4F6C1070-FC69-7346-96B1-50D36BCAB7E5}" type="datetimeFigureOut">
               <a:rPr lang="en-US" smtClean="0"/>
-              <a:t>1/28/26</a:t>
+              <a:t>2/2/26</a:t>
             </a:fld>
             <a:endParaRPr lang="en-US"/>
           </a:p>
@@ -3201,7 +3207,7 @@
           <a:p>
             <a:fld id="{4F6C1070-FC69-7346-96B1-50D36BCAB7E5}" type="datetimeFigureOut">
               <a:rPr lang="en-US" smtClean="0"/>
-              <a:t>1/28/26</a:t>
+              <a:t>2/2/26</a:t>
             </a:fld>
             <a:endParaRPr lang="en-US"/>
           </a:p>
@@ -3442,7 +3448,7 @@
           <a:p>
             <a:fld id="{4F6C1070-FC69-7346-96B1-50D36BCAB7E5}" type="datetimeFigureOut">
               <a:rPr lang="en-US" smtClean="0"/>
-              <a:t>1/28/26</a:t>
+              <a:t>2/2/26</a:t>
             </a:fld>
             <a:endParaRPr lang="en-US"/>
           </a:p>
@@ -3864,7 +3870,7 @@
           <p:cNvPr id="2" name="Title 1">
             <a:extLst>
               <a:ext uri="{FF2B5EF4-FFF2-40B4-BE49-F238E27FC236}">
-                <a16:creationId xmlns:a16="http://schemas.microsoft.com/office/drawing/2014/main" id="{E51FBE51-8633-823A-7559-65DCC1517E24}"/>
+                <a16:creationId xmlns:a16="http://schemas.microsoft.com/office/drawing/2014/main" id="{86F556F3-6286-6A6F-9689-63BFB9454AF1}"/>
               </a:ext>
             </a:extLst>
           </p:cNvPr>
@@ -3877,29 +3883,58 @@
         </p:nvSpPr>
         <p:spPr>
           <a:xfrm>
-            <a:off x="249382" y="365125"/>
-            <a:ext cx="11637818" cy="1325563"/>
+            <a:off x="838200" y="365125"/>
+            <a:ext cx="10515600" cy="526697"/>
           </a:xfrm>
         </p:spPr>
         <p:txBody>
           <a:bodyPr>
-            <a:normAutofit fontScale="90000"/>
+            <a:normAutofit/>
           </a:bodyPr>
           <a:lstStyle/>
           <a:p>
             <a:r>
-              <a:rPr lang="en-US" dirty="0"/>
-              <a:t>Size – size declines are happening for many reasons, common trend among stocks across N Pacific. Problem: Management is not accounting for this</a:t>
-            </a:r>
-          </a:p>
-        </p:txBody>
-      </p:sp>
-      <p:sp>
-        <p:nvSpPr>
-          <p:cNvPr id="4" name="TextBox 3">
-            <a:extLst>
-              <a:ext uri="{FF2B5EF4-FFF2-40B4-BE49-F238E27FC236}">
-                <a16:creationId xmlns:a16="http://schemas.microsoft.com/office/drawing/2014/main" id="{00610AA1-8017-D0F8-9719-03894D7B1879}"/>
+              <a:rPr lang="en-US" sz="2000" dirty="0"/>
+              <a:t>(Mean scaled values))</a:t>
+            </a:r>
+          </a:p>
+        </p:txBody>
+      </p:sp>
+      <p:pic>
+        <p:nvPicPr>
+          <p:cNvPr id="5" name="Content Placeholder 4" descr="A graph of different numbers&#10;&#10;AI-generated content may be incorrect.">
+            <a:extLst>
+              <a:ext uri="{FF2B5EF4-FFF2-40B4-BE49-F238E27FC236}">
+                <a16:creationId xmlns:a16="http://schemas.microsoft.com/office/drawing/2014/main" id="{D62FFF1F-1847-17C3-FF88-4C1BD100BA0B}"/>
+              </a:ext>
+            </a:extLst>
+          </p:cNvPr>
+          <p:cNvPicPr>
+            <a:picLocks noGrp="1" noChangeAspect="1"/>
+          </p:cNvPicPr>
+          <p:nvPr>
+            <p:ph idx="1"/>
+          </p:nvPr>
+        </p:nvPicPr>
+        <p:blipFill>
+          <a:blip r:embed="rId2"/>
+          <a:stretch>
+            <a:fillRect/>
+          </a:stretch>
+        </p:blipFill>
+        <p:spPr>
+          <a:xfrm>
+            <a:off x="3013023" y="57944"/>
+            <a:ext cx="9120885" cy="6840664"/>
+          </a:xfrm>
+        </p:spPr>
+      </p:pic>
+      <p:sp>
+        <p:nvSpPr>
+          <p:cNvPr id="6" name="TextBox 5">
+            <a:extLst>
+              <a:ext uri="{FF2B5EF4-FFF2-40B4-BE49-F238E27FC236}">
+                <a16:creationId xmlns:a16="http://schemas.microsoft.com/office/drawing/2014/main" id="{5E7FDAAB-51E8-48CA-414C-9C88C41DE28D}"/>
               </a:ext>
             </a:extLst>
           </p:cNvPr>
@@ -3908,8 +3943,8 @@
         </p:nvSpPr>
         <p:spPr>
           <a:xfrm>
-            <a:off x="249382" y="2011680"/>
-            <a:ext cx="2718116" cy="369332"/>
+            <a:off x="58092" y="6392712"/>
+            <a:ext cx="2413418" cy="369332"/>
           </a:xfrm>
           <a:prstGeom prst="rect">
             <a:avLst/>
@@ -3924,7 +3959,7 @@
           <a:p>
             <a:r>
               <a:rPr lang="en-US" dirty="0"/>
-              <a:t>Plot 1: show size declines</a:t>
+              <a:t>Data Source: CTC PSC</a:t>
             </a:r>
           </a:p>
         </p:txBody>
@@ -3932,7 +3967,7 @@
     </p:spTree>
     <p:extLst>
       <p:ext uri="{BB962C8B-B14F-4D97-AF65-F5344CB8AC3E}">
-        <p14:creationId xmlns:p14="http://schemas.microsoft.com/office/powerpoint/2010/main" val="4149726514"/>
+        <p14:creationId xmlns:p14="http://schemas.microsoft.com/office/powerpoint/2010/main" val="2685562052"/>
       </p:ext>
     </p:extLst>
   </p:cSld>
@@ -3959,37 +3994,97 @@
           <a:chExt cx="0" cy="0"/>
         </a:xfrm>
       </p:grpSpPr>
-      <p:sp>
-        <p:nvSpPr>
-          <p:cNvPr id="2" name="Title 1">
-            <a:extLst>
-              <a:ext uri="{FF2B5EF4-FFF2-40B4-BE49-F238E27FC236}">
-                <a16:creationId xmlns:a16="http://schemas.microsoft.com/office/drawing/2014/main" id="{5329C000-7BF3-78AA-F9D5-068C616CE946}"/>
-              </a:ext>
-            </a:extLst>
-          </p:cNvPr>
-          <p:cNvSpPr>
-            <a:spLocks noGrp="1"/>
-          </p:cNvSpPr>
-          <p:nvPr>
-            <p:ph type="title"/>
-          </p:nvPr>
-        </p:nvSpPr>
-        <p:spPr/>
-        <p:txBody>
-          <a:bodyPr/>
-          <a:lstStyle/>
-          <a:p>
-            <a:endParaRPr lang="en-US"/>
-          </a:p>
-        </p:txBody>
-      </p:sp>
-      <p:sp>
-        <p:nvSpPr>
-          <p:cNvPr id="4" name="TextBox 3">
-            <a:extLst>
-              <a:ext uri="{FF2B5EF4-FFF2-40B4-BE49-F238E27FC236}">
-                <a16:creationId xmlns:a16="http://schemas.microsoft.com/office/drawing/2014/main" id="{0F3F730C-6531-771F-EE53-9EAB5BBC3BE8}"/>
+      <p:pic>
+        <p:nvPicPr>
+          <p:cNvPr id="6" name="Picture 5" descr="A graph showing different types of numbers&#10;&#10;AI-generated content may be incorrect.">
+            <a:extLst>
+              <a:ext uri="{FF2B5EF4-FFF2-40B4-BE49-F238E27FC236}">
+                <a16:creationId xmlns:a16="http://schemas.microsoft.com/office/drawing/2014/main" id="{99EB9197-9920-6036-B8ED-F008756D35D2}"/>
+              </a:ext>
+            </a:extLst>
+          </p:cNvPr>
+          <p:cNvPicPr>
+            <a:picLocks noChangeAspect="1"/>
+          </p:cNvPicPr>
+          <p:nvPr/>
+        </p:nvPicPr>
+        <p:blipFill>
+          <a:blip r:embed="rId3"/>
+          <a:stretch>
+            <a:fillRect/>
+          </a:stretch>
+        </p:blipFill>
+        <p:spPr>
+          <a:xfrm>
+            <a:off x="3059084" y="0"/>
+            <a:ext cx="9132916" cy="6849687"/>
+          </a:xfrm>
+          <a:prstGeom prst="rect">
+            <a:avLst/>
+          </a:prstGeom>
+        </p:spPr>
+      </p:pic>
+      <p:sp>
+        <p:nvSpPr>
+          <p:cNvPr id="7" name="Title 1">
+            <a:extLst>
+              <a:ext uri="{FF2B5EF4-FFF2-40B4-BE49-F238E27FC236}">
+                <a16:creationId xmlns:a16="http://schemas.microsoft.com/office/drawing/2014/main" id="{308D802B-FD2D-31E6-1C1A-C4EAA7688EC8}"/>
+              </a:ext>
+            </a:extLst>
+          </p:cNvPr>
+          <p:cNvSpPr txBox="1">
+            <a:spLocks/>
+          </p:cNvSpPr>
+          <p:nvPr/>
+        </p:nvSpPr>
+        <p:spPr>
+          <a:xfrm>
+            <a:off x="0" y="128058"/>
+            <a:ext cx="10515600" cy="526697"/>
+          </a:xfrm>
+          <a:prstGeom prst="rect">
+            <a:avLst/>
+          </a:prstGeom>
+        </p:spPr>
+        <p:txBody>
+          <a:bodyPr vert="horz" lIns="91440" tIns="45720" rIns="91440" bIns="45720" rtlCol="0" anchor="b">
+            <a:normAutofit/>
+          </a:bodyPr>
+          <a:lstStyle>
+            <a:lvl1pPr algn="ctr" defTabSz="914400" rtl="0" eaLnBrk="1" latinLnBrk="0" hangingPunct="1">
+              <a:lnSpc>
+                <a:spcPct val="90000"/>
+              </a:lnSpc>
+              <a:spcBef>
+                <a:spcPct val="0"/>
+              </a:spcBef>
+              <a:buNone/>
+              <a:defRPr sz="6000" kern="1200">
+                <a:solidFill>
+                  <a:schemeClr val="tx1"/>
+                </a:solidFill>
+                <a:latin typeface="+mj-lt"/>
+                <a:ea typeface="+mj-ea"/>
+                <a:cs typeface="+mj-cs"/>
+              </a:defRPr>
+            </a:lvl1pPr>
+          </a:lstStyle>
+          <a:p>
+            <a:pPr algn="l"/>
+            <a:r>
+              <a:rPr lang="en-US" sz="2000" dirty="0"/>
+              <a:t>(Raw #s)</a:t>
+            </a:r>
+          </a:p>
+        </p:txBody>
+      </p:sp>
+      <p:sp>
+        <p:nvSpPr>
+          <p:cNvPr id="8" name="TextBox 7">
+            <a:extLst>
+              <a:ext uri="{FF2B5EF4-FFF2-40B4-BE49-F238E27FC236}">
+                <a16:creationId xmlns:a16="http://schemas.microsoft.com/office/drawing/2014/main" id="{3A91E8C7-87E8-D25B-367D-A57CB0775C68}"/>
               </a:ext>
             </a:extLst>
           </p:cNvPr>
@@ -3998,8 +4093,8 @@
         </p:nvSpPr>
         <p:spPr>
           <a:xfrm>
-            <a:off x="249382" y="2011680"/>
-            <a:ext cx="7153497" cy="369332"/>
+            <a:off x="58092" y="6392712"/>
+            <a:ext cx="2413418" cy="369332"/>
           </a:xfrm>
           <a:prstGeom prst="rect">
             <a:avLst/>
@@ -4014,7 +4109,7 @@
           <a:p>
             <a:r>
               <a:rPr lang="en-US" dirty="0"/>
-              <a:t>Plot 2: Summarize decline impacts on reproduction (using Malick et al)</a:t>
+              <a:t>Data Source: CTC PSC</a:t>
             </a:r>
           </a:p>
         </p:txBody>
@@ -4022,7 +4117,7 @@
     </p:spTree>
     <p:extLst>
       <p:ext uri="{BB962C8B-B14F-4D97-AF65-F5344CB8AC3E}">
-        <p14:creationId xmlns:p14="http://schemas.microsoft.com/office/powerpoint/2010/main" val="2856593937"/>
+        <p14:creationId xmlns:p14="http://schemas.microsoft.com/office/powerpoint/2010/main" val="2868827787"/>
       </p:ext>
     </p:extLst>
   </p:cSld>
@@ -4054,7 +4149,7 @@
           <p:cNvPr id="2" name="Title 1">
             <a:extLst>
               <a:ext uri="{FF2B5EF4-FFF2-40B4-BE49-F238E27FC236}">
-                <a16:creationId xmlns:a16="http://schemas.microsoft.com/office/drawing/2014/main" id="{3E8C8D1B-B448-15B9-6E78-D010773F258F}"/>
+                <a16:creationId xmlns:a16="http://schemas.microsoft.com/office/drawing/2014/main" id="{E51FBE51-8633-823A-7559-65DCC1517E24}"/>
               </a:ext>
             </a:extLst>
           </p:cNvPr>
@@ -4065,12 +4160,22 @@
             <p:ph type="title"/>
           </p:nvPr>
         </p:nvSpPr>
-        <p:spPr/>
-        <p:txBody>
-          <a:bodyPr/>
-          <a:lstStyle/>
-          <a:p>
-            <a:endParaRPr lang="en-US"/>
+        <p:spPr>
+          <a:xfrm>
+            <a:off x="249382" y="365125"/>
+            <a:ext cx="11637818" cy="1325563"/>
+          </a:xfrm>
+        </p:spPr>
+        <p:txBody>
+          <a:bodyPr>
+            <a:normAutofit fontScale="90000"/>
+          </a:bodyPr>
+          <a:lstStyle/>
+          <a:p>
+            <a:r>
+              <a:rPr lang="en-US" dirty="0"/>
+              <a:t>Size – size declines are happening for many reasons, common trend among stocks across N Pacific. Problem: Management is not accounting for this</a:t>
+            </a:r>
           </a:p>
         </p:txBody>
       </p:sp>
@@ -4079,7 +4184,7 @@
           <p:cNvPr id="4" name="TextBox 3">
             <a:extLst>
               <a:ext uri="{FF2B5EF4-FFF2-40B4-BE49-F238E27FC236}">
-                <a16:creationId xmlns:a16="http://schemas.microsoft.com/office/drawing/2014/main" id="{2C8A8429-D105-7BBE-DCDF-D418F56191FB}"/>
+                <a16:creationId xmlns:a16="http://schemas.microsoft.com/office/drawing/2014/main" id="{00610AA1-8017-D0F8-9719-03894D7B1879}"/>
               </a:ext>
             </a:extLst>
           </p:cNvPr>
@@ -4089,7 +4194,7 @@
         <p:spPr>
           <a:xfrm>
             <a:off x="249382" y="2011680"/>
-            <a:ext cx="7393819" cy="369332"/>
+            <a:ext cx="9213804" cy="1477328"/>
           </a:xfrm>
           <a:prstGeom prst="rect">
             <a:avLst/>
@@ -4104,7 +4209,47 @@
           <a:p>
             <a:r>
               <a:rPr lang="en-US" dirty="0"/>
-              <a:t>Plot 3: how would accounting for size declines change escapement goals</a:t>
+              <a:t>Plot 1: Plot size declines</a:t>
+            </a:r>
+          </a:p>
+          <a:p>
+            <a:r>
+              <a:rPr lang="en-US" dirty="0"/>
+              <a:t>	Output from a Linear mixed effects model? </a:t>
+            </a:r>
+          </a:p>
+          <a:p>
+            <a:r>
+              <a:rPr lang="en-US" dirty="0"/>
+              <a:t>Sensu </a:t>
+            </a:r>
+            <a:r>
+              <a:rPr lang="en-US" dirty="0" err="1"/>
+              <a:t>Ohlberger</a:t>
+            </a:r>
+            <a:r>
+              <a:rPr lang="en-US" dirty="0"/>
+              <a:t> et al 2018</a:t>
+            </a:r>
+          </a:p>
+          <a:p>
+            <a:r>
+              <a:rPr lang="en-US" dirty="0"/>
+              <a:t>- Outcome = average mm change in size for each age for the last ~30 years on </a:t>
+            </a:r>
+            <a:r>
+              <a:rPr lang="en-US" dirty="0" err="1"/>
+              <a:t>wa</a:t>
+            </a:r>
+            <a:r>
+              <a:rPr lang="en-US" dirty="0"/>
+              <a:t> outer coast</a:t>
+            </a:r>
+          </a:p>
+          <a:p>
+            <a:r>
+              <a:rPr lang="en-US" dirty="0"/>
+              <a:t>	</a:t>
             </a:r>
           </a:p>
         </p:txBody>
@@ -4112,7 +4257,7 @@
     </p:spTree>
     <p:extLst>
       <p:ext uri="{BB962C8B-B14F-4D97-AF65-F5344CB8AC3E}">
-        <p14:creationId xmlns:p14="http://schemas.microsoft.com/office/powerpoint/2010/main" val="852140476"/>
+        <p14:creationId xmlns:p14="http://schemas.microsoft.com/office/powerpoint/2010/main" val="4149726514"/>
       </p:ext>
     </p:extLst>
   </p:cSld>
@@ -4139,40 +4284,160 @@
           <a:chExt cx="0" cy="0"/>
         </a:xfrm>
       </p:grpSpPr>
-      <p:pic>
-        <p:nvPicPr>
-          <p:cNvPr id="5" name="Picture 4">
-            <a:extLst>
-              <a:ext uri="{FF2B5EF4-FFF2-40B4-BE49-F238E27FC236}">
-                <a16:creationId xmlns:a16="http://schemas.microsoft.com/office/drawing/2014/main" id="{ED5EE69B-4CEF-CB8B-AAFA-FC0D92CF9B70}"/>
-              </a:ext>
-            </a:extLst>
-          </p:cNvPr>
-          <p:cNvPicPr>
-            <a:picLocks noChangeAspect="1"/>
-          </p:cNvPicPr>
+      <p:sp>
+        <p:nvSpPr>
+          <p:cNvPr id="2" name="Title 1">
+            <a:extLst>
+              <a:ext uri="{FF2B5EF4-FFF2-40B4-BE49-F238E27FC236}">
+                <a16:creationId xmlns:a16="http://schemas.microsoft.com/office/drawing/2014/main" id="{5329C000-7BF3-78AA-F9D5-068C616CE946}"/>
+              </a:ext>
+            </a:extLst>
+          </p:cNvPr>
+          <p:cNvSpPr>
+            <a:spLocks noGrp="1"/>
+          </p:cNvSpPr>
+          <p:nvPr>
+            <p:ph type="title"/>
+          </p:nvPr>
+        </p:nvSpPr>
+        <p:spPr/>
+        <p:txBody>
+          <a:bodyPr/>
+          <a:lstStyle/>
+          <a:p>
+            <a:endParaRPr lang="en-US"/>
+          </a:p>
+        </p:txBody>
+      </p:sp>
+      <p:sp>
+        <p:nvSpPr>
+          <p:cNvPr id="4" name="TextBox 3">
+            <a:extLst>
+              <a:ext uri="{FF2B5EF4-FFF2-40B4-BE49-F238E27FC236}">
+                <a16:creationId xmlns:a16="http://schemas.microsoft.com/office/drawing/2014/main" id="{0F3F730C-6531-771F-EE53-9EAB5BBC3BE8}"/>
+              </a:ext>
+            </a:extLst>
+          </p:cNvPr>
+          <p:cNvSpPr txBox="1"/>
           <p:nvPr/>
-        </p:nvPicPr>
-        <p:blipFill>
-          <a:blip r:embed="rId3"/>
-          <a:stretch>
-            <a:fillRect/>
-          </a:stretch>
-        </p:blipFill>
+        </p:nvSpPr>
         <p:spPr>
           <a:xfrm>
-            <a:off x="1524000" y="0"/>
-            <a:ext cx="9144000" cy="6858000"/>
+            <a:off x="249382" y="2011680"/>
+            <a:ext cx="7153497" cy="369332"/>
           </a:xfrm>
           <a:prstGeom prst="rect">
             <a:avLst/>
           </a:prstGeom>
+          <a:noFill/>
         </p:spPr>
-      </p:pic>
+        <p:txBody>
+          <a:bodyPr wrap="none" rtlCol="0">
+            <a:spAutoFit/>
+          </a:bodyPr>
+          <a:lstStyle/>
+          <a:p>
+            <a:r>
+              <a:rPr lang="en-US" dirty="0"/>
+              <a:t>Plot 2: Summarize decline impacts on reproduction (using Malick et al)</a:t>
+            </a:r>
+          </a:p>
+        </p:txBody>
+      </p:sp>
     </p:spTree>
     <p:extLst>
       <p:ext uri="{BB962C8B-B14F-4D97-AF65-F5344CB8AC3E}">
-        <p14:creationId xmlns:p14="http://schemas.microsoft.com/office/powerpoint/2010/main" val="2868827787"/>
+        <p14:creationId xmlns:p14="http://schemas.microsoft.com/office/powerpoint/2010/main" val="2856593937"/>
+      </p:ext>
+    </p:extLst>
+  </p:cSld>
+  <p:clrMapOvr>
+    <a:masterClrMapping/>
+  </p:clrMapOvr>
+</p:sld>
+</file>
+
+<file path=ppt/slides/slide5.xml><?xml version="1.0" encoding="utf-8"?>
+<p:sld xmlns:a="http://schemas.openxmlformats.org/drawingml/2006/main" xmlns:r="http://schemas.openxmlformats.org/officeDocument/2006/relationships" xmlns:p="http://schemas.openxmlformats.org/presentationml/2006/main">
+  <p:cSld>
+    <p:spTree>
+      <p:nvGrpSpPr>
+        <p:cNvPr id="1" name=""/>
+        <p:cNvGrpSpPr/>
+        <p:nvPr/>
+      </p:nvGrpSpPr>
+      <p:grpSpPr>
+        <a:xfrm>
+          <a:off x="0" y="0"/>
+          <a:ext cx="0" cy="0"/>
+          <a:chOff x="0" y="0"/>
+          <a:chExt cx="0" cy="0"/>
+        </a:xfrm>
+      </p:grpSpPr>
+      <p:sp>
+        <p:nvSpPr>
+          <p:cNvPr id="2" name="Title 1">
+            <a:extLst>
+              <a:ext uri="{FF2B5EF4-FFF2-40B4-BE49-F238E27FC236}">
+                <a16:creationId xmlns:a16="http://schemas.microsoft.com/office/drawing/2014/main" id="{3E8C8D1B-B448-15B9-6E78-D010773F258F}"/>
+              </a:ext>
+            </a:extLst>
+          </p:cNvPr>
+          <p:cNvSpPr>
+            <a:spLocks noGrp="1"/>
+          </p:cNvSpPr>
+          <p:nvPr>
+            <p:ph type="title"/>
+          </p:nvPr>
+        </p:nvSpPr>
+        <p:spPr/>
+        <p:txBody>
+          <a:bodyPr/>
+          <a:lstStyle/>
+          <a:p>
+            <a:endParaRPr lang="en-US"/>
+          </a:p>
+        </p:txBody>
+      </p:sp>
+      <p:sp>
+        <p:nvSpPr>
+          <p:cNvPr id="4" name="TextBox 3">
+            <a:extLst>
+              <a:ext uri="{FF2B5EF4-FFF2-40B4-BE49-F238E27FC236}">
+                <a16:creationId xmlns:a16="http://schemas.microsoft.com/office/drawing/2014/main" id="{2C8A8429-D105-7BBE-DCDF-D418F56191FB}"/>
+              </a:ext>
+            </a:extLst>
+          </p:cNvPr>
+          <p:cNvSpPr txBox="1"/>
+          <p:nvPr/>
+        </p:nvSpPr>
+        <p:spPr>
+          <a:xfrm>
+            <a:off x="249382" y="2011680"/>
+            <a:ext cx="7393819" cy="369332"/>
+          </a:xfrm>
+          <a:prstGeom prst="rect">
+            <a:avLst/>
+          </a:prstGeom>
+          <a:noFill/>
+        </p:spPr>
+        <p:txBody>
+          <a:bodyPr wrap="none" rtlCol="0">
+            <a:spAutoFit/>
+          </a:bodyPr>
+          <a:lstStyle/>
+          <a:p>
+            <a:r>
+              <a:rPr lang="en-US" dirty="0"/>
+              <a:t>Plot 3: how would accounting for size declines change escapement goals</a:t>
+            </a:r>
+          </a:p>
+        </p:txBody>
+      </p:sp>
+    </p:spTree>
+    <p:extLst>
+      <p:ext uri="{BB962C8B-B14F-4D97-AF65-F5344CB8AC3E}">
+        <p14:creationId xmlns:p14="http://schemas.microsoft.com/office/powerpoint/2010/main" val="852140476"/>
       </p:ext>
     </p:extLst>
   </p:cSld>

</xml_diff>